<commit_message>
Link and format fixes
</commit_message>
<xml_diff>
--- a/2025/ISIS_November_2025/3_Thursday_November_6th/2_Writing_a_component/pptx/1_Writing_a_component.pptx
+++ b/2025/ISIS_November_2025/3_Thursday_November_6th/2_Writing_a_component/pptx/1_Writing_a_component.pptx
@@ -112,6 +112,11 @@
       </a:defRPr>
     </a:lvl9pPr>
   </p:defaultTextStyle>
+  <p:extLst>
+    <p:ext uri="{EFAFB233-063F-42B5-8137-9DF3F51BA10A}">
+      <p15:sldGuideLst xmlns:p15="http://schemas.microsoft.com/office/powerpoint/2012/main"/>
+    </p:ext>
+  </p:extLst>
 </p:presentation>
 </file>
 
@@ -45926,8 +45931,8 @@
         </p:nvSpPr>
         <p:spPr>
           <a:xfrm>
-            <a:off x="1774800" y="426240"/>
-            <a:ext cx="9311760" cy="972000"/>
+            <a:off x="2051246" y="319864"/>
+            <a:ext cx="9311760" cy="548668"/>
           </a:xfrm>
           <a:prstGeom prst="rect">
             <a:avLst/>
@@ -45961,15 +45966,33 @@
               </a:lnSpc>
             </a:pPr>
             <a:r>
-              <a:rPr lang="en-US" sz="3000" b="1" strike="noStrike" spc="-1">
+              <a:rPr lang="en-US" sz="3000" b="1" strike="noStrike" spc="-1" dirty="0">
                 <a:solidFill>
                   <a:srgbClr val="000000"/>
                 </a:solidFill>
                 <a:latin typeface="Arial"/>
               </a:rPr>
-              <a:t>Write your own McStas component </a:t>
+              <a:t>Write your own </a:t>
             </a:r>
-            <a:endParaRPr lang="en-US" sz="3000" b="0" strike="noStrike" spc="-1">
+            <a:r>
+              <a:rPr lang="en-US" sz="3000" b="1" strike="noStrike" spc="-1" dirty="0" err="1">
+                <a:solidFill>
+                  <a:srgbClr val="000000"/>
+                </a:solidFill>
+                <a:latin typeface="Arial"/>
+              </a:rPr>
+              <a:t>McStas</a:t>
+            </a:r>
+            <a:r>
+              <a:rPr lang="en-US" sz="3000" b="1" strike="noStrike" spc="-1" dirty="0">
+                <a:solidFill>
+                  <a:srgbClr val="000000"/>
+                </a:solidFill>
+                <a:latin typeface="Arial"/>
+              </a:rPr>
+              <a:t> component </a:t>
+            </a:r>
+            <a:endParaRPr lang="en-US" sz="3000" b="0" strike="noStrike" spc="-1" dirty="0">
               <a:latin typeface="Arial"/>
             </a:endParaRPr>
           </a:p>
@@ -45983,8 +46006,8 @@
         </p:nvSpPr>
         <p:spPr>
           <a:xfrm>
-            <a:off x="1774800" y="1521046"/>
-            <a:ext cx="9311760" cy="2541240"/>
+            <a:off x="1774800" y="1100471"/>
+            <a:ext cx="9311760" cy="3382390"/>
           </a:xfrm>
           <a:prstGeom prst="rect">
             <a:avLst/>
@@ -46059,7 +46082,7 @@
                 </a:solidFill>
                 <a:latin typeface="Arial"/>
               </a:rPr>
-              <a:t>Write a component that models a semi-permeable mirror. i.e. a mirror with reflectivity&lt;1, which also uses focused sampling.</a:t>
+              <a:t>Write a component that models a semi-permeable mirror. i.e. a mirror with scalar reflectivity&lt;1, which also uses focused sampling.</a:t>
             </a:r>
             <a:endParaRPr lang="en-US" sz="1800" b="0" strike="noStrike" spc="-1" dirty="0">
               <a:latin typeface="Arial"/>
@@ -46158,7 +46181,7 @@
                 <a:latin typeface="Arial"/>
                 <a:ea typeface="Arial"/>
               </a:rPr>
-              <a:t>Wednesday</a:t>
+              <a:t>Thursday</a:t>
             </a:r>
             <a:r>
               <a:rPr lang="en-US" sz="1800" b="0" strike="noStrike" spc="-1" dirty="0">
@@ -46168,7 +46191,7 @@
                 <a:latin typeface="Arial"/>
                 <a:ea typeface="Arial"/>
               </a:rPr>
-              <a:t> – item 4</a:t>
+              <a:t> – item 2</a:t>
             </a:r>
             <a:br>
               <a:rPr dirty="0"/>
@@ -46181,7 +46204,7 @@
                 <a:ea typeface="Arial"/>
                 <a:hlinkClick r:id="rId2"/>
               </a:rPr>
-              <a:t>https://github.com/mccode-dev/Schools/tree/master/2025/ISIS_November_2025/3_Thursday_November_6th/4_Writing_a_component/Write_a_component</a:t>
+              <a:t>https://github.com/mccode-dev/Schools/blob/master/2025/ISIS_November_2025/3_Thursday_November_6th/2_Writing_a_component/README.md</a:t>
             </a:r>
             <a:endParaRPr lang="en-US" sz="1400" spc="-1" dirty="0">
               <a:solidFill>
@@ -46212,7 +46235,7 @@
                 <a:latin typeface="Arial"/>
                 <a:ea typeface="Arial"/>
               </a:rPr>
-              <a:t>Start with an </a:t>
+              <a:t>Start with the </a:t>
             </a:r>
             <a:r>
               <a:rPr lang="en-US" sz="1800" b="1" strike="noStrike" spc="-1" dirty="0">
@@ -46232,7 +46255,30 @@
                 <a:latin typeface="Arial"/>
                 <a:ea typeface="Arial"/>
               </a:rPr>
-              <a:t> – it has most of the </a:t>
+              <a:t> – copied in place for convenience.</a:t>
+            </a:r>
+          </a:p>
+          <a:p>
+            <a:pPr marL="720">
+              <a:lnSpc>
+                <a:spcPct val="100000"/>
+              </a:lnSpc>
+              <a:spcBef>
+                <a:spcPts val="400"/>
+              </a:spcBef>
+              <a:buClr>
+                <a:srgbClr val="000000"/>
+              </a:buClr>
+            </a:pPr>
+            <a:r>
+              <a:rPr lang="en-US" sz="1800" b="0" strike="noStrike" spc="-1" dirty="0">
+                <a:solidFill>
+                  <a:srgbClr val="000000"/>
+                </a:solidFill>
+                <a:latin typeface="Arial"/>
+                <a:ea typeface="Arial"/>
+              </a:rPr>
+              <a:t>(it has most of the </a:t>
             </a:r>
             <a:r>
               <a:rPr lang="en-US" sz="1800" b="0" strike="noStrike" spc="-1" dirty="0" err="1">
@@ -46252,7 +46298,7 @@
                 <a:latin typeface="Arial"/>
                 <a:ea typeface="Arial"/>
               </a:rPr>
-              <a:t> structure present already.</a:t>
+              <a:t> structure present already.)</a:t>
             </a:r>
             <a:endParaRPr lang="en-US" sz="1800" b="0" strike="noStrike" spc="-1" dirty="0">
               <a:latin typeface="Arial"/>
@@ -46349,8 +46395,8 @@
           </a:p>
         </p:txBody>
       </p:sp>
-      <mc:AlternateContent xmlns:mc="http://schemas.openxmlformats.org/markup-compatibility/2006" xmlns:a14="http://schemas.microsoft.com/office/drawing/2010/main">
-        <mc:Choice Requires="a14">
+      <mc:AlternateContent xmlns:mc="http://schemas.openxmlformats.org/markup-compatibility/2006">
+        <mc:Choice xmlns:a14="http://schemas.microsoft.com/office/drawing/2010/main" Requires="a14">
           <p:sp>
             <p:nvSpPr>
               <p:cNvPr id="663" name="Formula 4"/>
@@ -46359,8 +46405,8 @@
             </p:nvSpPr>
             <p:spPr>
               <a:xfrm>
-                <a:off x="2516040" y="4967280"/>
-                <a:ext cx="1000080" cy="761760"/>
+                <a:off x="2516039" y="4967280"/>
+                <a:ext cx="1343579" cy="761760"/>
               </a:xfrm>
               <a:prstGeom prst="rect">
                 <a:avLst/>
@@ -46370,6 +46416,7 @@
               <a:bodyPr/>
               <a:lstStyle/>
               <a:p>
+                <a:pPr/>
                 <a14:m>
                   <m:oMathPara xmlns:m="http://schemas.openxmlformats.org/officeDocument/2006/math">
                     <m:oMathParaPr>
@@ -46379,7 +46426,7 @@
                       <m:sSub>
                         <m:sSubPr>
                           <m:ctrlPr>
-                            <a:rPr>
+                            <a:rPr i="1">
                               <a:latin typeface="Cambria Math" panose="02040503050406030204" pitchFamily="18" charset="0"/>
                             </a:rPr>
                           </m:ctrlPr>
@@ -46454,12 +46501,49 @@
                     </m:oMath>
                   </m:oMathPara>
                 </a14:m>
-                <a:endParaRPr/>
+                <a:endParaRPr dirty="0"/>
               </a:p>
             </p:txBody>
           </p:sp>
         </mc:Choice>
-        <mc:Fallback xmlns:p15="http://schemas.microsoft.com/office/powerpoint/2012/main" xmlns:p14="http://schemas.microsoft.com/office/powerpoint/2010/main" xmlns=""/>
+        <mc:Fallback>
+          <p:sp>
+            <p:nvSpPr>
+              <p:cNvPr id="663" name="Formula 4"/>
+              <p:cNvSpPr txBox="1">
+                <a:spLocks noRot="1" noChangeAspect="1" noMove="1" noResize="1" noEditPoints="1" noAdjustHandles="1" noChangeArrowheads="1" noChangeShapeType="1" noTextEdit="1"/>
+              </p:cNvSpPr>
+              <p:nvPr/>
+            </p:nvSpPr>
+            <p:spPr>
+              <a:xfrm>
+                <a:off x="2516039" y="4967280"/>
+                <a:ext cx="1343579" cy="761760"/>
+              </a:xfrm>
+              <a:prstGeom prst="rect">
+                <a:avLst/>
+              </a:prstGeom>
+              <a:blipFill>
+                <a:blip r:embed="rId3"/>
+                <a:stretch>
+                  <a:fillRect/>
+                </a:stretch>
+              </a:blipFill>
+            </p:spPr>
+            <p:txBody>
+              <a:bodyPr/>
+              <a:lstStyle/>
+              <a:p>
+                <a:r>
+                  <a:rPr lang="en-DK">
+                    <a:noFill/>
+                  </a:rPr>
+                  <a:t> </a:t>
+                </a:r>
+              </a:p>
+            </p:txBody>
+          </p:sp>
+        </mc:Fallback>
       </mc:AlternateContent>
       <mc:AlternateContent xmlns:mc="http://schemas.openxmlformats.org/markup-compatibility/2006" xmlns:a14="http://schemas.microsoft.com/office/drawing/2010/main">
         <mc:Choice Requires="a14">
@@ -46482,6 +46566,7 @@
               <a:bodyPr/>
               <a:lstStyle/>
               <a:p>
+                <a:pPr/>
                 <a14:m>
                   <m:oMathPara xmlns:m="http://schemas.openxmlformats.org/officeDocument/2006/math">
                     <m:oMathParaPr>
@@ -46491,7 +46576,7 @@
                       <m:sSub>
                         <m:sSubPr>
                           <m:ctrlPr>
-                            <a:rPr>
+                            <a:rPr i="1">
                               <a:latin typeface="Cambria Math" panose="02040503050406030204" pitchFamily="18" charset="0"/>
                             </a:rPr>
                           </m:ctrlPr>
@@ -46521,7 +46606,7 @@
             </p:txBody>
           </p:sp>
         </mc:Choice>
-        <mc:Fallback xmlns:p15="http://schemas.microsoft.com/office/powerpoint/2012/main" xmlns:p14="http://schemas.microsoft.com/office/powerpoint/2010/main" xmlns=""/>
+        <mc:Fallback xmlns="" xmlns:p14="http://schemas.microsoft.com/office/powerpoint/2010/main" xmlns:p15="http://schemas.microsoft.com/office/powerpoint/2012/main"/>
       </mc:AlternateContent>
       <mc:AlternateContent xmlns:mc="http://schemas.openxmlformats.org/markup-compatibility/2006" xmlns:a14="http://schemas.microsoft.com/office/drawing/2010/main">
         <mc:Choice Requires="a14">
@@ -46544,6 +46629,7 @@
               <a:bodyPr/>
               <a:lstStyle/>
               <a:p>
+                <a:pPr/>
                 <a14:m>
                   <m:oMathPara xmlns:m="http://schemas.openxmlformats.org/officeDocument/2006/math">
                     <m:oMathParaPr>
@@ -46564,7 +46650,7 @@
             </p:txBody>
           </p:sp>
         </mc:Choice>
-        <mc:Fallback xmlns:p15="http://schemas.microsoft.com/office/powerpoint/2012/main" xmlns:p14="http://schemas.microsoft.com/office/powerpoint/2010/main" xmlns=""/>
+        <mc:Fallback xmlns="" xmlns:p14="http://schemas.microsoft.com/office/powerpoint/2010/main" xmlns:p15="http://schemas.microsoft.com/office/powerpoint/2012/main"/>
       </mc:AlternateContent>
       <mc:AlternateContent xmlns:mc="http://schemas.openxmlformats.org/markup-compatibility/2006" xmlns:a14="http://schemas.microsoft.com/office/drawing/2010/main">
         <mc:Choice Requires="a14">
@@ -46587,6 +46673,7 @@
               <a:bodyPr/>
               <a:lstStyle/>
               <a:p>
+                <a:pPr/>
                 <a14:m>
                   <m:oMathPara xmlns:m="http://schemas.openxmlformats.org/officeDocument/2006/math">
                     <m:oMathParaPr>
@@ -46596,7 +46683,7 @@
                       <m:sSub>
                         <m:sSubPr>
                           <m:ctrlPr>
-                            <a:rPr>
+                            <a:rPr i="1">
                               <a:latin typeface="Cambria Math" panose="02040503050406030204" pitchFamily="18" charset="0"/>
                             </a:rPr>
                           </m:ctrlPr>
@@ -46626,7 +46713,7 @@
             </p:txBody>
           </p:sp>
         </mc:Choice>
-        <mc:Fallback xmlns:p15="http://schemas.microsoft.com/office/powerpoint/2012/main" xmlns:p14="http://schemas.microsoft.com/office/powerpoint/2010/main" xmlns=""/>
+        <mc:Fallback xmlns="" xmlns:p14="http://schemas.microsoft.com/office/powerpoint/2010/main" xmlns:p15="http://schemas.microsoft.com/office/powerpoint/2012/main"/>
       </mc:AlternateContent>
       <p:sp>
         <p:nvSpPr>
@@ -46751,7 +46838,7 @@
             </p:txBody>
           </p:sp>
         </mc:Choice>
-        <mc:Fallback xmlns:p15="http://schemas.microsoft.com/office/powerpoint/2012/main" xmlns:p14="http://schemas.microsoft.com/office/powerpoint/2010/main" xmlns=""/>
+        <mc:Fallback xmlns="" xmlns:p14="http://schemas.microsoft.com/office/powerpoint/2010/main" xmlns:p15="http://schemas.microsoft.com/office/powerpoint/2012/main"/>
       </mc:AlternateContent>
     </p:spTree>
   </p:cSld>

</xml_diff>